<commit_message>
Move pending-offer deadline to 31 Dec 2026 and rebuild deliverables
- 04_data.sql: response deadline for open final-placement offers is now
  2026-12-31 (was 2026-12-15)
- Re-ran tests (91/91), re-recorded the demo, refreshed screenshots, and
  rebuilt the deck, report, guide, testing report and runbook with PDFs

Co-Authored-By: Claude Opus 5.5 <noreply@anthropic.com>
</commit_message>
<xml_diff>
--- a/deliverables/PlaceIQ_Presentation.pptx
+++ b/deliverables/PlaceIQ_Presentation.pptx
@@ -124,7 +124,7 @@
   <p:extLst>
     <p:ext uri="{521415D9-36F7-43E2-AB2F-B90AF26B5E84}">
       <p14:sectionLst xmlns:p14="http://schemas.microsoft.com/office/powerpoint/2010/main">
-        <p14:section name="M1 · Problem &amp; EER" id="{21361137-f4ac-3670-1ad8-388a2b1c8572}">
+        <p14:section name="M1 · Problem &amp; EER" id="{50932df4-2e47-9ec2-71e1-18d30560c018}">
           <p14:sldIdLst>
             <p14:sldId id="256"/>
             <p14:sldId id="257"/>
@@ -133,14 +133,14 @@
             <p14:sldId id="260"/>
           </p14:sldIdLst>
         </p14:section>
-        <p14:section name="M2 · Schema &amp; normalization" id="{2c5f5e86-dfca-254b-e8df-c684a304528b}">
+        <p14:section name="M2 · Schema &amp; normalization" id="{a1c77df3-face-04e4-83a8-f4bb8621addb}">
           <p14:sldIdLst>
             <p14:sldId id="261"/>
             <p14:sldId id="262"/>
             <p14:sldId id="263"/>
           </p14:sldIdLst>
         </p14:section>
-        <p14:section name="M3 · DDL, data &amp; queries" id="{93c5c595-bb6e-7850-010d-fab82f1829fe}">
+        <p14:section name="M3 · DDL, data &amp; queries" id="{c914741e-1c69-eedc-2233-46c3c83ac2ca}">
           <p14:sldIdLst>
             <p14:sldId id="264"/>
             <p14:sldId id="265"/>
@@ -148,7 +148,7 @@
             <p14:sldId id="267"/>
           </p14:sldIdLst>
         </p14:section>
-        <p14:section name="M4 · Rules, transactions &amp; performance" id="{b2c66745-5d3d-910a-5e2d-46bae883bb2e}">
+        <p14:section name="M4 · Rules, transactions &amp; performance" id="{aa55bc4d-2628-0973-77ae-09618874c3b8}">
           <p14:sldIdLst>
             <p14:sldId id="268"/>
             <p14:sldId id="269"/>
@@ -980,13 +980,13 @@
                 <c:formatCode>General</c:formatCode>
                 <c:ptCount val="3"/>
                 <c:pt idx="0">
-                  <c:v>62.609</c:v>
+                  <c:v>62.654</c:v>
                 </c:pt>
                 <c:pt idx="1">
-                  <c:v>0.041</c:v>
+                  <c:v>0.029</c:v>
                 </c:pt>
                 <c:pt idx="2">
-                  <c:v>0.017</c:v>
+                  <c:v>0.021</c:v>
                 </c:pt>
               </c:numCache>
             </c:numRef>
@@ -2437,7 +2437,7 @@
             <a:r>
               <a:rPr lang="en-US" dirty="0"/>
               <a:t>[M4 · [Member 4] · 13:50–14:15]
-Our live tables are small, so we built a 600,000-row application archive to measure indexing honestly. Without an index, PostgreSQL scans the whole table: 62.6 milliseconds. A composite B-tree on job_id and status: 0.041 milliseconds, about 1,527 times faster. A partial index that only covers open applications is 26 times smaller and faster still.
+Our live tables are small, so we built a 600,000-row application archive to measure indexing honestly. Without an index, PostgreSQL scans the whole table: 62.7 milliseconds. A composite B-tree on job_id and status: 0.029 milliseconds, about 2,160 times faster. A partial index that only covers open applications is 26 times smaller and faster still.
 One lesson surprised us: we expected PostgreSQL 18 to ignore the index for a filter on status alone. It actually used it, but by reading the entire index — 4,383 blocks versus 3. The leading-column rule is about seeking, not about whether the index appears in the plan.</a:t>
             </a:r>
             <a:endParaRPr lang="en-US" dirty="0"/>
@@ -10117,7 +10117,7 @@
                 <a:ea typeface="Cambria" pitchFamily="34" charset="-122"/>
                 <a:cs typeface="Cambria" pitchFamily="34" charset="-120"/>
               </a:rPr>
-              <a:t>1,527× faster</a:t>
+              <a:t>2,160× faster</a:t>
             </a:r>
             <a:endParaRPr lang="en-US" sz="3600" dirty="0"/>
           </a:p>

</xml_diff>